<commit_message>
Add initial version of Edge Pitch Deck presentation
</commit_message>
<xml_diff>
--- a/docs/AI for Education_University of Malaya_UM-Gunners_PitchDeck.pptx
+++ b/docs/AI for Education_University of Malaya_UM-Gunners_PitchDeck.pptx
@@ -133,7 +133,7 @@
           <a:p>
             <a:r>
               <a:rPr sz="1200"/>
-              <a:t>Grounding rate by language (same question)</a:t>
+              <a:t>Curriculum-grounding rate by language</a:t>
             </a:r>
           </a:p>
         </c:rich>
@@ -11198,17 +11198,100 @@
           </a:p>
         </p:txBody>
       </p:sp>
+      <p:sp>
+        <p:nvSpPr>
+          <p:cNvPr id="5" name="Rounded Rectangle 4"/>
+          <p:cNvSpPr/>
+          <p:nvPr/>
+        </p:nvSpPr>
+        <p:spPr>
+          <a:xfrm>
+            <a:off x="640080" y="1463040"/>
+            <a:ext cx="10972800" cy="777240"/>
+          </a:xfrm>
+          <a:prstGeom prst="roundRect">
+            <a:avLst/>
+          </a:prstGeom>
+          <a:solidFill>
+            <a:srgbClr val="EAF6EE"/>
+          </a:solidFill>
+          <a:ln>
+            <a:noFill/>
+          </a:ln>
+          <a:effectLst/>
+        </p:spPr>
+        <p:style>
+          <a:lnRef idx="1">
+            <a:schemeClr val="accent1"/>
+          </a:lnRef>
+          <a:fillRef idx="3">
+            <a:schemeClr val="accent1"/>
+          </a:fillRef>
+          <a:effectRef idx="2">
+            <a:schemeClr val="accent1"/>
+          </a:effectRef>
+          <a:fontRef idx="minor">
+            <a:schemeClr val="lt1"/>
+          </a:fontRef>
+        </p:style>
+        <p:txBody>
+          <a:bodyPr rtlCol="0" anchor="ctr"/>
+          <a:lstStyle/>
+          <a:p>
+            <a:pPr algn="ctr"/>
+          </a:p>
+        </p:txBody>
+      </p:sp>
+      <p:sp>
+        <p:nvSpPr>
+          <p:cNvPr id="6" name="TextBox 5"/>
+          <p:cNvSpPr txBox="1"/>
+          <p:nvPr/>
+        </p:nvSpPr>
+        <p:spPr>
+          <a:xfrm>
+            <a:off x="868680" y="1517904"/>
+            <a:ext cx="10607040" cy="640080"/>
+          </a:xfrm>
+          <a:prstGeom prst="rect">
+            <a:avLst/>
+          </a:prstGeom>
+          <a:noFill/>
+        </p:spPr>
+        <p:txBody>
+          <a:bodyPr wrap="square" anchor="ctr">
+            <a:spAutoFit/>
+          </a:bodyPr>
+          <a:lstStyle/>
+          <a:p>
+            <a:pPr algn="l">
+              <a:spcAft>
+                <a:spcPts val="600"/>
+              </a:spcAft>
+            </a:pPr>
+            <a:r>
+              <a:rPr sz="1500" b="1" i="0">
+                <a:solidFill>
+                  <a:srgbClr val="1E8E3E"/>
+                </a:solidFill>
+                <a:latin typeface="Calibri"/>
+              </a:rPr>
+              <a:t>✓  100% of questions answered in EVERY language tested — 0% non-response. No student is ever left without an answer.</a:t>
+            </a:r>
+          </a:p>
+        </p:txBody>
+      </p:sp>
       <p:graphicFrame>
         <p:nvGraphicFramePr>
-          <p:cNvPr id="5" name="Chart 4"/>
+          <p:cNvPr id="7" name="Chart 6"/>
           <p:cNvGraphicFramePr>
             <a:graphicFrameLocks noGrp="1"/>
           </p:cNvGraphicFramePr>
           <p:nvPr/>
         </p:nvGraphicFramePr>
         <p:xfrm>
-          <a:off x="548640" y="1645920"/>
-          <a:ext cx="6035040" cy="4297680"/>
+          <a:off x="548640" y="2423160"/>
+          <a:ext cx="6035040" cy="3566160"/>
         </p:xfrm>
         <a:graphic>
           <a:graphicData uri="http://schemas.openxmlformats.org/drawingml/2006/chart">
@@ -11218,14 +11301,14 @@
       </p:graphicFrame>
       <p:sp>
         <p:nvSpPr>
-          <p:cNvPr id="6" name="TextBox 5"/>
+          <p:cNvPr id="8" name="TextBox 7"/>
           <p:cNvSpPr txBox="1"/>
           <p:nvPr/>
         </p:nvSpPr>
         <p:spPr>
           <a:xfrm>
-            <a:off x="6766560" y="1737360"/>
-            <a:ext cx="4937760" cy="3108960"/>
+            <a:off x="6766560" y="2468880"/>
+            <a:ext cx="4937760" cy="2194560"/>
           </a:xfrm>
           <a:prstGeom prst="rect">
             <a:avLst/>
@@ -11244,13 +11327,13 @@
               </a:spcAft>
             </a:pPr>
             <a:r>
-              <a:rPr sz="1400" b="0" i="0">
+              <a:rPr sz="1300" b="0" i="0">
                 <a:solidFill>
                   <a:srgbClr val="1E1E28"/>
                 </a:solidFill>
                 <a:latin typeface="Calibri"/>
               </a:rPr>
-              <a:t>•  Same question, varied language → English 100% vs Thai 50% grounding = measured bias</a:t>
+              <a:t>•  Same question, varied language: a measured bias (English 100% vs Thai 50% grounding)</a:t>
             </a:r>
           </a:p>
           <a:p>
@@ -11260,7 +11343,7 @@
               </a:spcAft>
             </a:pPr>
             <a:r>
-              <a:rPr sz="1400" b="0" i="0">
+              <a:rPr sz="1300" b="0" i="0">
                 <a:solidFill>
                   <a:srgbClr val="1E1E28"/>
                 </a:solidFill>
@@ -11276,33 +11359,33 @@
               </a:spcAft>
             </a:pPr>
             <a:r>
-              <a:rPr sz="1400" b="0" i="0">
+              <a:rPr sz="1300" b="0" i="0">
                 <a:solidFill>
                   <a:srgbClr val="1E1E28"/>
                 </a:solidFill>
                 <a:latin typeface="Calibri"/>
               </a:rPr>
-              <a:t>•  Fix: cross-lingual retrieval → Thai/Viet 62%, Iban fully closed; 0% non-response</a:t>
-            </a:r>
-          </a:p>
-        </p:txBody>
-      </p:sp>
-      <p:sp>
-        <p:nvSpPr>
-          <p:cNvPr id="7" name="Rounded Rectangle 6"/>
+              <a:t>•  Fix: cross-lingual retrieval → Thai/Viet 62%, Iban fully closed</a:t>
+            </a:r>
+          </a:p>
+        </p:txBody>
+      </p:sp>
+      <p:sp>
+        <p:nvSpPr>
+          <p:cNvPr id="9" name="Rounded Rectangle 8"/>
           <p:cNvSpPr/>
           <p:nvPr/>
         </p:nvSpPr>
         <p:spPr>
           <a:xfrm>
-            <a:off x="6766560" y="4937760"/>
-            <a:ext cx="4937760" cy="1005840"/>
+            <a:off x="6766560" y="4572000"/>
+            <a:ext cx="4937760" cy="1371600"/>
           </a:xfrm>
           <a:prstGeom prst="roundRect">
             <a:avLst/>
           </a:prstGeom>
           <a:solidFill>
-            <a:srgbClr val="EAF6EE"/>
+            <a:srgbClr val="F1EEFC"/>
           </a:solidFill>
           <a:ln>
             <a:noFill/>
@@ -11335,7 +11418,7 @@
             <a:r>
               <a:rPr sz="1300" b="1" i="0">
                 <a:solidFill>
-                  <a:srgbClr val="1E8E3E"/>
+                  <a:srgbClr val="5B3FE0"/>
                 </a:solidFill>
                 <a:latin typeface="Calibri"/>
               </a:rPr>
@@ -11355,7 +11438,7 @@
                 </a:solidFill>
                 <a:latin typeface="Calibri"/>
               </a:rPr>
-              <a:t>RBAC + per-teacher audit · encryption (LUKS + USB) · parental consent · retention &amp; erasure</a:t>
+              <a:t>RBAC + per-teacher audit log · encryption (LUKS + encrypted USB) · parental consent record · retention purge &amp; right-to-erasure</a:t>
             </a:r>
           </a:p>
         </p:txBody>

</xml_diff>